<commit_message>
Fix corrupt pptx: use separate paragraphs for pentagram node labels
Raw newline characters inside run text (a:t) made PowerPoint refuse to
open the file. Split the English/Danish node labels into two paragraphs
so the output is valid OOXML.

https://claude.ai/code/session_016CCnnAeMfx8c9tWP28Tc5q
</commit_message>
<xml_diff>
--- a/fast-fashion-presentation/Fast_Fashion_Presentation.pptx
+++ b/fast-fashion-presentation/Fast_Fashion_Presentation.pptx
@@ -6455,9 +6455,15 @@
                 </a:solidFill>
                 <a:latin typeface="Calibri"/>
               </a:rPr>
-              <a:t>Topic
-</a:t>
-            </a:r>
+              <a:t>Topic</a:t>
+            </a:r>
+          </a:p>
+          <a:p>
+            <a:pPr algn="ctr">
+              <a:lnSpc>
+                <a:spcPct val="95000"/>
+              </a:lnSpc>
+            </a:pPr>
             <a:r>
               <a:rPr sz="1100" i="1">
                 <a:solidFill>
@@ -6524,9 +6530,15 @@
                 </a:solidFill>
                 <a:latin typeface="Calibri"/>
               </a:rPr>
-              <a:t>Receiver
-</a:t>
-            </a:r>
+              <a:t>Receiver</a:t>
+            </a:r>
+          </a:p>
+          <a:p>
+            <a:pPr algn="ctr">
+              <a:lnSpc>
+                <a:spcPct val="95000"/>
+              </a:lnSpc>
+            </a:pPr>
             <a:r>
               <a:rPr sz="1100" i="1">
                 <a:solidFill>
@@ -6593,9 +6605,15 @@
                 </a:solidFill>
                 <a:latin typeface="Calibri"/>
               </a:rPr>
-              <a:t>Language
-</a:t>
-            </a:r>
+              <a:t>Language</a:t>
+            </a:r>
+          </a:p>
+          <a:p>
+            <a:pPr algn="ctr">
+              <a:lnSpc>
+                <a:spcPct val="95000"/>
+              </a:lnSpc>
+            </a:pPr>
             <a:r>
               <a:rPr sz="1100" i="1">
                 <a:solidFill>
@@ -6662,9 +6680,15 @@
                 </a:solidFill>
                 <a:latin typeface="Calibri"/>
               </a:rPr>
-              <a:t>Circumstances
-</a:t>
-            </a:r>
+              <a:t>Circumstances</a:t>
+            </a:r>
+          </a:p>
+          <a:p>
+            <a:pPr algn="ctr">
+              <a:lnSpc>
+                <a:spcPct val="95000"/>
+              </a:lnSpc>
+            </a:pPr>
             <a:r>
               <a:rPr sz="1100" i="1">
                 <a:solidFill>
@@ -6731,9 +6755,15 @@
                 </a:solidFill>
                 <a:latin typeface="Calibri"/>
               </a:rPr>
-              <a:t>Sender
-</a:t>
-            </a:r>
+              <a:t>Sender</a:t>
+            </a:r>
+          </a:p>
+          <a:p>
+            <a:pPr algn="ctr">
+              <a:lnSpc>
+                <a:spcPct val="95000"/>
+              </a:lnSpc>
+            </a:pPr>
             <a:r>
               <a:rPr sz="1100" i="1">
                 <a:solidFill>

</xml_diff>